<commit_message>
fix(examples): refactor Slide 2 to two-column layout with distinct text and image regions
</commit_message>
<xml_diff>
--- a/examples/No Knead Bread.pptx
+++ b/examples/No Knead Bread.pptx
@@ -3192,10 +3192,15 @@
             <a:spLocks noGrp="1"/>
           </p:cNvSpPr>
           <p:nvPr>
-            <p:ph idx="1"/>
-          </p:nvPr>
-        </p:nvSpPr>
-        <p:spPr/>
+            <p:ph idx="1" sz="half"/>
+          </p:nvPr>
+        </p:nvSpPr>
+        <p:spPr>
+          <a:xfrm>
+            <a:off x="731520" y="1645920"/>
+            <a:ext cx="4114800" cy="4389120"/>
+          </a:xfrm>
+        </p:spPr>
         <p:txBody>
           <a:bodyPr/>
           <a:lstStyle/>
@@ -3206,16 +3211,32 @@
             </a:r>
           </a:p>
           <a:p>
+            <a:pPr>
+              <a:spcBef>
+                <a:spcPts val="1400"/>
+              </a:spcBef>
+            </a:pPr>
             <a:r>
               <a:rPr lang="en-US"/>
               <a:t>Requiring zero special equipment and just four basic pantry staples, this method delivers a golden, blistered crust and a moist, airy crumb.</a:t>
             </a:r>
           </a:p>
+          <a:p>
+            <a:pPr>
+              <a:spcBef>
+                <a:spcPts val="1400"/>
+              </a:spcBef>
+            </a:pPr>
+            <a:r>
+              <a:rPr lang="en-US"/>
+              <a:t>A slow, 12 to 18-hour room-temperature fermentation develops rich flavor and a chewy artisan texture without any manual kneading.</a:t>
+            </a:r>
+          </a:p>
         </p:txBody>
       </p:sp>
       <p:pic>
         <p:nvPicPr>
-          <p:cNvPr id="4" name="Artisan Bread Loaf" descr="A freshly baked round loaf of golden-brown artisanal no-knead bread with a crispy, flour-dusted crust."/>
+          <p:cNvPr id="4" name="Artisan Bread Loaf" descr="A freshly baked round loaf of golden-brown artisanal no-knead bread with a crispy, flour-dusted crust in a Dutch oven."/>
           <p:cNvPicPr>
             <a:picLocks noChangeAspect="1"/>
           </p:cNvPicPr>
@@ -3229,7 +3250,7 @@
         </p:blipFill>
         <p:spPr>
           <a:xfrm>
-            <a:off x="5029200" y="2011680"/>
+            <a:off x="5029200" y="1828800"/>
             <a:ext cx="3474720" cy="2303890"/>
           </a:xfrm>
           <a:prstGeom prst="rect">

</xml_diff>

<commit_message>
fix(examples): polish typography and spacing across slides to prevent text overflow
</commit_message>
<xml_diff>
--- a/examples/No Knead Bread.pptx
+++ b/examples/No Knead Bread.pptx
@@ -3117,7 +3117,12 @@
           <a:lstStyle/>
           <a:p>
             <a:r>
-              <a:rPr lang="en-US"/>
+              <a:rPr lang="en-US" sz="4000" b="1">
+                <a:solidFill>
+                  <a:srgbClr val="0F172A"/>
+                </a:solidFill>
+                <a:latin typeface="Calibri"/>
+              </a:rPr>
               <a:t>No Knead Bread</a:t>
             </a:r>
           </a:p>
@@ -3139,7 +3144,12 @@
           <a:lstStyle/>
           <a:p>
             <a:r>
-              <a:rPr lang="en-US"/>
+              <a:rPr lang="en-US" sz="1800" b="0">
+                <a:solidFill>
+                  <a:srgbClr val="475569"/>
+                </a:solidFill>
+                <a:latin typeface="Calibri"/>
+              </a:rPr>
               <a:t>No kneading required, 4 simple ingredients, baked in a Dutch Oven.</a:t>
             </a:r>
           </a:p>
@@ -3179,7 +3189,12 @@
           <a:lstStyle/>
           <a:p>
             <a:r>
-              <a:rPr lang="en-US"/>
+              <a:rPr lang="en-US" sz="3000" b="1">
+                <a:solidFill>
+                  <a:srgbClr val="0F172A"/>
+                </a:solidFill>
+                <a:latin typeface="Calibri"/>
+              </a:rPr>
               <a:t>Introduction &amp; Overview</a:t>
             </a:r>
           </a:p>
@@ -3205,30 +3220,62 @@
           <a:bodyPr/>
           <a:lstStyle/>
           <a:p>
-            <a:r>
-              <a:rPr lang="en-US"/>
-              <a:t>The simplicity of this no knead bread is what makes it a household favorite. Your entire home will fill with the aroma of fresh artisan bakery bread as it bakes.</a:t>
-            </a:r>
-          </a:p>
-          <a:p>
             <a:pPr>
               <a:spcBef>
-                <a:spcPts val="1400"/>
+                <a:spcPts val="0"/>
               </a:spcBef>
+              <a:spcAft>
+                <a:spcPts val="1200"/>
+              </a:spcAft>
+              <a:buNone/>
             </a:pPr>
             <a:r>
-              <a:rPr lang="en-US"/>
-              <a:t>Requiring zero special equipment and just four basic pantry staples, this method delivers a golden, blistered crust and a moist, airy crumb.</a:t>
+              <a:rPr lang="en-US" sz="1500" b="0">
+                <a:solidFill>
+                  <a:srgbClr val="334155"/>
+                </a:solidFill>
+                <a:latin typeface="Calibri"/>
+              </a:rPr>
+              <a:t>The simplicity of this no-knead bread is what makes it a household favorite. Your entire home will fill with the aroma of fresh artisan bakery bread as it bakes.</a:t>
             </a:r>
           </a:p>
           <a:p>
             <a:pPr>
               <a:spcBef>
-                <a:spcPts val="1400"/>
+                <a:spcPts val="0"/>
               </a:spcBef>
+              <a:spcAft>
+                <a:spcPts val="1200"/>
+              </a:spcAft>
+              <a:buNone/>
             </a:pPr>
             <a:r>
-              <a:rPr lang="en-US"/>
+              <a:rPr lang="en-US" sz="1500" b="0">
+                <a:solidFill>
+                  <a:srgbClr val="334155"/>
+                </a:solidFill>
+                <a:latin typeface="Calibri"/>
+              </a:rPr>
+              <a:t>Requiring zero special equipment and just four basic pantry staples, this method delivers a golden, blistered crust and a moist, airy crumb.</a:t>
+            </a:r>
+          </a:p>
+          <a:p>
+            <a:pPr>
+              <a:spcBef>
+                <a:spcPts val="0"/>
+              </a:spcBef>
+              <a:spcAft>
+                <a:spcPts val="0"/>
+              </a:spcAft>
+              <a:buNone/>
+            </a:pPr>
+            <a:r>
+              <a:rPr lang="en-US" sz="1500" b="0">
+                <a:solidFill>
+                  <a:srgbClr val="334155"/>
+                </a:solidFill>
+                <a:latin typeface="Calibri"/>
+              </a:rPr>
               <a:t>A slow, 12 to 18-hour room-temperature fermentation develops rich flavor and a chewy artisan texture without any manual kneading.</a:t>
             </a:r>
           </a:p>
@@ -3250,7 +3297,7 @@
         </p:blipFill>
         <p:spPr>
           <a:xfrm>
-            <a:off x="5029200" y="1828800"/>
+            <a:off x="5029200" y="1645920"/>
             <a:ext cx="3474720" cy="2303890"/>
           </a:xfrm>
           <a:prstGeom prst="rect">
@@ -3292,7 +3339,12 @@
           <a:lstStyle/>
           <a:p>
             <a:r>
-              <a:rPr lang="en-US"/>
+              <a:rPr lang="en-US" sz="3000" b="1">
+                <a:solidFill>
+                  <a:srgbClr val="0F172A"/>
+                </a:solidFill>
+                <a:latin typeface="Calibri"/>
+              </a:rPr>
               <a:t>Ingredients</a:t>
             </a:r>
           </a:p>
@@ -3307,8 +3359,8 @@
           <p:nvPr/>
         </p:nvGraphicFramePr>
         <p:xfrm>
-          <a:off x="914400" y="1828800"/>
-          <a:ext cx="7315200" cy="3200400"/>
+          <a:off x="914400" y="1645920"/>
+          <a:ext cx="7315200" cy="2926080"/>
         </p:xfrm>
         <a:graphic>
           <a:graphicData uri="http://schemas.openxmlformats.org/drawingml/2006/table">
@@ -3321,14 +3373,19 @@
                 <a:gridCol w="2438400"/>
                 <a:gridCol w="2438400"/>
               </a:tblGrid>
-              <a:tr h="640080">
+              <a:tr h="585216">
                 <a:tc>
                   <a:txBody>
                     <a:bodyPr/>
                     <a:lstStyle/>
                     <a:p>
                       <a:r>
-                        <a:rPr lang="en-US"/>
+                        <a:rPr lang="en-US" sz="1500" b="1">
+                          <a:solidFill>
+                            <a:srgbClr val="0F172A"/>
+                          </a:solidFill>
+                          <a:latin typeface="Calibri"/>
+                        </a:rPr>
                         <a:t>Ingredient</a:t>
                       </a:r>
                     </a:p>
@@ -3341,7 +3398,12 @@
                     <a:lstStyle/>
                     <a:p>
                       <a:r>
-                        <a:rPr lang="en-US"/>
+                        <a:rPr lang="en-US" sz="1500" b="1">
+                          <a:solidFill>
+                            <a:srgbClr val="0F172A"/>
+                          </a:solidFill>
+                          <a:latin typeface="Calibri"/>
+                        </a:rPr>
                         <a:t>Quantity</a:t>
                       </a:r>
                     </a:p>
@@ -3354,7 +3416,12 @@
                     <a:lstStyle/>
                     <a:p>
                       <a:r>
-                        <a:rPr lang="en-US"/>
+                        <a:rPr lang="en-US" sz="1500" b="1">
+                          <a:solidFill>
+                            <a:srgbClr val="0F172A"/>
+                          </a:solidFill>
+                          <a:latin typeface="Calibri"/>
+                        </a:rPr>
                         <a:t>Notes</a:t>
                       </a:r>
                     </a:p>
@@ -3362,14 +3429,19 @@
                   <a:tcPr/>
                 </a:tc>
               </a:tr>
-              <a:tr h="640080">
+              <a:tr h="585216">
                 <a:tc>
                   <a:txBody>
                     <a:bodyPr/>
                     <a:lstStyle/>
                     <a:p>
                       <a:r>
-                        <a:rPr lang="en-US"/>
+                        <a:rPr lang="en-US" sz="1400" b="0">
+                          <a:solidFill>
+                            <a:srgbClr val="334155"/>
+                          </a:solidFill>
+                          <a:latin typeface="Calibri"/>
+                        </a:rPr>
                         <a:t>All-Purpose Flour</a:t>
                       </a:r>
                     </a:p>
@@ -3382,7 +3454,12 @@
                     <a:lstStyle/>
                     <a:p>
                       <a:r>
-                        <a:rPr lang="en-US"/>
+                        <a:rPr lang="en-US" sz="1400" b="0">
+                          <a:solidFill>
+                            <a:srgbClr val="334155"/>
+                          </a:solidFill>
+                          <a:latin typeface="Calibri"/>
+                        </a:rPr>
                         <a:t>3 cups</a:t>
                       </a:r>
                     </a:p>
@@ -3395,7 +3472,12 @@
                     <a:lstStyle/>
                     <a:p>
                       <a:r>
-                        <a:rPr lang="en-US"/>
+                        <a:rPr lang="en-US" sz="1400" b="0">
+                          <a:solidFill>
+                            <a:srgbClr val="334155"/>
+                          </a:solidFill>
+                          <a:latin typeface="Calibri"/>
+                        </a:rPr>
                         <a:t>Unbleached white flour preferred</a:t>
                       </a:r>
                     </a:p>
@@ -3403,14 +3485,19 @@
                   <a:tcPr/>
                 </a:tc>
               </a:tr>
-              <a:tr h="640080">
+              <a:tr h="585216">
                 <a:tc>
                   <a:txBody>
                     <a:bodyPr/>
                     <a:lstStyle/>
                     <a:p>
                       <a:r>
-                        <a:rPr lang="en-US"/>
+                        <a:rPr lang="en-US" sz="1400" b="0">
+                          <a:solidFill>
+                            <a:srgbClr val="334155"/>
+                          </a:solidFill>
+                          <a:latin typeface="Calibri"/>
+                        </a:rPr>
                         <a:t>Salt</a:t>
                       </a:r>
                     </a:p>
@@ -3423,7 +3510,12 @@
                     <a:lstStyle/>
                     <a:p>
                       <a:r>
-                        <a:rPr lang="en-US"/>
+                        <a:rPr lang="en-US" sz="1400" b="0">
+                          <a:solidFill>
+                            <a:srgbClr val="334155"/>
+                          </a:solidFill>
+                          <a:latin typeface="Calibri"/>
+                        </a:rPr>
                         <a:t>1 3/4 tsp</a:t>
                       </a:r>
                     </a:p>
@@ -3436,7 +3528,12 @@
                     <a:lstStyle/>
                     <a:p>
                       <a:r>
-                        <a:rPr lang="en-US"/>
+                        <a:rPr lang="en-US" sz="1400" b="0">
+                          <a:solidFill>
+                            <a:srgbClr val="334155"/>
+                          </a:solidFill>
+                          <a:latin typeface="Calibri"/>
+                        </a:rPr>
                         <a:t>Fine sea salt or kosher salt</a:t>
                       </a:r>
                     </a:p>
@@ -3444,14 +3541,19 @@
                   <a:tcPr/>
                 </a:tc>
               </a:tr>
-              <a:tr h="640080">
+              <a:tr h="585216">
                 <a:tc>
                   <a:txBody>
                     <a:bodyPr/>
                     <a:lstStyle/>
                     <a:p>
                       <a:r>
-                        <a:rPr lang="en-US"/>
+                        <a:rPr lang="en-US" sz="1400" b="0">
+                          <a:solidFill>
+                            <a:srgbClr val="334155"/>
+                          </a:solidFill>
+                          <a:latin typeface="Calibri"/>
+                        </a:rPr>
                         <a:t>Active Dry Yeast</a:t>
                       </a:r>
                     </a:p>
@@ -3464,7 +3566,12 @@
                     <a:lstStyle/>
                     <a:p>
                       <a:r>
-                        <a:rPr lang="en-US"/>
+                        <a:rPr lang="en-US" sz="1400" b="0">
+                          <a:solidFill>
+                            <a:srgbClr val="334155"/>
+                          </a:solidFill>
+                          <a:latin typeface="Calibri"/>
+                        </a:rPr>
                         <a:t>1/2 tsp</a:t>
                       </a:r>
                     </a:p>
@@ -3477,7 +3584,12 @@
                     <a:lstStyle/>
                     <a:p>
                       <a:r>
-                        <a:rPr lang="en-US"/>
+                        <a:rPr lang="en-US" sz="1400" b="0">
+                          <a:solidFill>
+                            <a:srgbClr val="334155"/>
+                          </a:solidFill>
+                          <a:latin typeface="Calibri"/>
+                        </a:rPr>
                         <a:t>Instant or dry active yeast</a:t>
                       </a:r>
                     </a:p>
@@ -3485,14 +3597,19 @@
                   <a:tcPr/>
                 </a:tc>
               </a:tr>
-              <a:tr h="640080">
+              <a:tr h="585216">
                 <a:tc>
                   <a:txBody>
                     <a:bodyPr/>
                     <a:lstStyle/>
                     <a:p>
                       <a:r>
-                        <a:rPr lang="en-US"/>
+                        <a:rPr lang="en-US" sz="1400" b="0">
+                          <a:solidFill>
+                            <a:srgbClr val="334155"/>
+                          </a:solidFill>
+                          <a:latin typeface="Calibri"/>
+                        </a:rPr>
                         <a:t>Water</a:t>
                       </a:r>
                     </a:p>
@@ -3505,7 +3622,12 @@
                     <a:lstStyle/>
                     <a:p>
                       <a:r>
-                        <a:rPr lang="en-US"/>
+                        <a:rPr lang="en-US" sz="1400" b="0">
+                          <a:solidFill>
+                            <a:srgbClr val="334155"/>
+                          </a:solidFill>
+                          <a:latin typeface="Calibri"/>
+                        </a:rPr>
                         <a:t>1 1/2 cups</a:t>
                       </a:r>
                     </a:p>
@@ -3518,7 +3640,12 @@
                     <a:lstStyle/>
                     <a:p>
                       <a:r>
-                        <a:rPr lang="en-US"/>
+                        <a:rPr lang="en-US" sz="1400" b="0">
+                          <a:solidFill>
+                            <a:srgbClr val="334155"/>
+                          </a:solidFill>
+                          <a:latin typeface="Calibri"/>
+                        </a:rPr>
                         <a:t>Room temperature (approx. 70°F)</a:t>
                       </a:r>
                     </a:p>
@@ -3564,7 +3691,12 @@
           <a:lstStyle/>
           <a:p>
             <a:r>
-              <a:rPr lang="en-US"/>
+              <a:rPr lang="en-US" sz="3000" b="1">
+                <a:solidFill>
+                  <a:srgbClr val="0F172A"/>
+                </a:solidFill>
+                <a:latin typeface="Calibri"/>
+              </a:rPr>
               <a:t>Step-by-Step Instructions</a:t>
             </a:r>
           </a:p>
@@ -3580,43 +3712,132 @@
             <p:ph idx="1"/>
           </p:nvPr>
         </p:nvSpPr>
-        <p:spPr/>
-        <p:txBody>
-          <a:bodyPr/>
-          <a:lstStyle/>
-          <a:p>
-            <a:r>
-              <a:rPr lang="en-US"/>
+        <p:spPr>
+          <a:xfrm>
+            <a:off x="0" y="1645920"/>
+            <a:ext cx="0" cy="4572000"/>
+          </a:xfrm>
+        </p:spPr>
+        <p:txBody>
+          <a:bodyPr/>
+          <a:lstStyle/>
+          <a:p>
+            <a:pPr>
+              <a:spcBef>
+                <a:spcPts val="0"/>
+              </a:spcBef>
+              <a:spcAft>
+                <a:spcPts val="600"/>
+              </a:spcAft>
+              <a:buNone/>
+            </a:pPr>
+            <a:r>
+              <a:rPr lang="en-US" sz="1400" b="0">
+                <a:solidFill>
+                  <a:srgbClr val="334155"/>
+                </a:solidFill>
+                <a:latin typeface="Calibri"/>
+              </a:rPr>
               <a:t>1. In a large bowl, whisk together flour, salt, and yeast.</a:t>
             </a:r>
           </a:p>
           <a:p>
-            <a:r>
-              <a:rPr lang="en-US"/>
+            <a:pPr>
+              <a:spcBef>
+                <a:spcPts val="0"/>
+              </a:spcBef>
+              <a:spcAft>
+                <a:spcPts val="600"/>
+              </a:spcAft>
+              <a:buNone/>
+            </a:pPr>
+            <a:r>
+              <a:rPr lang="en-US" sz="1400" b="0">
+                <a:solidFill>
+                  <a:srgbClr val="334155"/>
+                </a:solidFill>
+                <a:latin typeface="Calibri"/>
+              </a:rPr>
               <a:t>2. Add room-temperature water; stir with a wooden spoon until a shaggy dough forms.</a:t>
             </a:r>
           </a:p>
           <a:p>
-            <a:r>
-              <a:rPr lang="en-US"/>
+            <a:pPr>
+              <a:spcBef>
+                <a:spcPts val="0"/>
+              </a:spcBef>
+              <a:spcAft>
+                <a:spcPts val="600"/>
+              </a:spcAft>
+              <a:buNone/>
+            </a:pPr>
+            <a:r>
+              <a:rPr lang="en-US" sz="1400" b="0">
+                <a:solidFill>
+                  <a:srgbClr val="334155"/>
+                </a:solidFill>
+                <a:latin typeface="Calibri"/>
+              </a:rPr>
               <a:t>3. Cover tightly with plastic wrap; let rest at room temperature for 12 to 18 hours.</a:t>
             </a:r>
           </a:p>
           <a:p>
-            <a:r>
-              <a:rPr lang="en-US"/>
+            <a:pPr>
+              <a:spcBef>
+                <a:spcPts val="0"/>
+              </a:spcBef>
+              <a:spcAft>
+                <a:spcPts val="600"/>
+              </a:spcAft>
+              <a:buNone/>
+            </a:pPr>
+            <a:r>
+              <a:rPr lang="en-US" sz="1400" b="0">
+                <a:solidFill>
+                  <a:srgbClr val="334155"/>
+                </a:solidFill>
+                <a:latin typeface="Calibri"/>
+              </a:rPr>
               <a:t>4. Preheat oven and covered cast iron Dutch oven to 450°F (230°C).</a:t>
             </a:r>
           </a:p>
           <a:p>
-            <a:r>
-              <a:rPr lang="en-US"/>
+            <a:pPr>
+              <a:spcBef>
+                <a:spcPts val="0"/>
+              </a:spcBef>
+              <a:spcAft>
+                <a:spcPts val="600"/>
+              </a:spcAft>
+              <a:buNone/>
+            </a:pPr>
+            <a:r>
+              <a:rPr lang="en-US" sz="1400" b="0">
+                <a:solidFill>
+                  <a:srgbClr val="334155"/>
+                </a:solidFill>
+                <a:latin typeface="Calibri"/>
+              </a:rPr>
               <a:t>5. Gently turn dough onto a floured surface, shape into a ball, and transfer to hot pot.</a:t>
             </a:r>
           </a:p>
           <a:p>
-            <a:r>
-              <a:rPr lang="en-US"/>
+            <a:pPr>
+              <a:spcBef>
+                <a:spcPts val="0"/>
+              </a:spcBef>
+              <a:spcAft>
+                <a:spcPts val="600"/>
+              </a:spcAft>
+              <a:buNone/>
+            </a:pPr>
+            <a:r>
+              <a:rPr lang="en-US" sz="1400" b="0">
+                <a:solidFill>
+                  <a:srgbClr val="334155"/>
+                </a:solidFill>
+                <a:latin typeface="Calibri"/>
+              </a:rPr>
               <a:t>6. Bake covered for 30 minutes, then uncovered for 15 to 20 minutes until golden brown.</a:t>
             </a:r>
           </a:p>
@@ -3656,7 +3877,12 @@
           <a:lstStyle/>
           <a:p>
             <a:r>
-              <a:rPr lang="en-US"/>
+              <a:rPr lang="en-US" sz="3000" b="1">
+                <a:solidFill>
+                  <a:srgbClr val="0F172A"/>
+                </a:solidFill>
+                <a:latin typeface="Calibri"/>
+              </a:rPr>
               <a:t>Serving &amp; Storage Tips</a:t>
             </a:r>
           </a:p>
@@ -3672,31 +3898,115 @@
             <p:ph idx="1"/>
           </p:nvPr>
         </p:nvSpPr>
-        <p:spPr/>
-        <p:txBody>
-          <a:bodyPr/>
-          <a:lstStyle/>
-          <a:p>
-            <a:r>
-              <a:rPr lang="en-US"/>
-              <a:t>Cool Completely: Allow loaf to rest on a wire cooling rack for at least 1 hour before slicing to prevent gumminess.</a:t>
-            </a:r>
-          </a:p>
-          <a:p>
-            <a:r>
-              <a:rPr lang="en-US"/>
-              <a:t>Storage: Store at room temperature in a paper bag or bread box for up to 3 days. Avoid plastic bags.</a:t>
-            </a:r>
-          </a:p>
-          <a:p>
-            <a:r>
-              <a:rPr lang="en-US"/>
-              <a:t>Serving: Perfect warm with salted European butter, extra virgin olive oil, or hearty soups.</a:t>
-            </a:r>
-          </a:p>
-          <a:p>
-            <a:r>
-              <a:rPr lang="en-US">
+        <p:spPr>
+          <a:xfrm>
+            <a:off x="0" y="1645920"/>
+            <a:ext cx="0" cy="4389120"/>
+          </a:xfrm>
+        </p:spPr>
+        <p:txBody>
+          <a:bodyPr/>
+          <a:lstStyle/>
+          <a:p>
+            <a:pPr>
+              <a:spcBef>
+                <a:spcPts val="0"/>
+              </a:spcBef>
+              <a:spcAft>
+                <a:spcPts val="1000"/>
+              </a:spcAft>
+              <a:buNone/>
+            </a:pPr>
+            <a:r>
+              <a:rPr lang="en-US" sz="1500" b="1">
+                <a:solidFill>
+                  <a:srgbClr val="0F172A"/>
+                </a:solidFill>
+                <a:latin typeface="Calibri"/>
+              </a:rPr>
+              <a:t>Cool Completely: </a:t>
+            </a:r>
+            <a:r>
+              <a:rPr lang="en-US" sz="1500" b="0">
+                <a:solidFill>
+                  <a:srgbClr val="334155"/>
+                </a:solidFill>
+                <a:latin typeface="Calibri"/>
+              </a:rPr>
+              <a:t>Allow loaf to rest on a wire cooling rack for at least 1 hour before slicing to prevent gumminess.</a:t>
+            </a:r>
+          </a:p>
+          <a:p>
+            <a:pPr>
+              <a:spcBef>
+                <a:spcPts val="0"/>
+              </a:spcBef>
+              <a:spcAft>
+                <a:spcPts val="1000"/>
+              </a:spcAft>
+              <a:buNone/>
+            </a:pPr>
+            <a:r>
+              <a:rPr lang="en-US" sz="1500" b="1">
+                <a:solidFill>
+                  <a:srgbClr val="0F172A"/>
+                </a:solidFill>
+                <a:latin typeface="Calibri"/>
+              </a:rPr>
+              <a:t>Storage: </a:t>
+            </a:r>
+            <a:r>
+              <a:rPr lang="en-US" sz="1500" b="0">
+                <a:solidFill>
+                  <a:srgbClr val="334155"/>
+                </a:solidFill>
+                <a:latin typeface="Calibri"/>
+              </a:rPr>
+              <a:t>Store at room temperature in a paper bag or bread box for up to 3 days. Avoid plastic bags.</a:t>
+            </a:r>
+          </a:p>
+          <a:p>
+            <a:pPr>
+              <a:spcBef>
+                <a:spcPts val="0"/>
+              </a:spcBef>
+              <a:spcAft>
+                <a:spcPts val="1000"/>
+              </a:spcAft>
+              <a:buNone/>
+            </a:pPr>
+            <a:r>
+              <a:rPr lang="en-US" sz="1500" b="1">
+                <a:solidFill>
+                  <a:srgbClr val="0F172A"/>
+                </a:solidFill>
+                <a:latin typeface="Calibri"/>
+              </a:rPr>
+              <a:t>Serving: </a:t>
+            </a:r>
+            <a:r>
+              <a:rPr lang="en-US" sz="1500" b="0">
+                <a:solidFill>
+                  <a:srgbClr val="334155"/>
+                </a:solidFill>
+                <a:latin typeface="Calibri"/>
+              </a:rPr>
+              <a:t>Perfect warm with salted European butter, extra virgin olive oil, or hearty soups.</a:t>
+            </a:r>
+          </a:p>
+          <a:p>
+            <a:pPr>
+              <a:spcBef>
+                <a:spcPts val="800"/>
+              </a:spcBef>
+              <a:buNone/>
+            </a:pPr>
+            <a:r>
+              <a:rPr lang="en-US" sz="1500" b="1">
+                <a:solidFill>
+                  <a:srgbClr val="0284C7"/>
+                </a:solidFill>
+                <a:latin typeface="Calibri"/>
                 <a:hlinkClick r:id="rId2"/>
               </a:rPr>
               <a:t>Explore the complete Artisan Dutch Oven Baking Guide</a:t>

</xml_diff>

<commit_message>
feat(examples): modernize Slide 4 and Slide 5 with structured cards, phase badges, and crisp typography
</commit_message>
<xml_diff>
--- a/examples/No Knead Bread.pptx
+++ b/examples/No Knead Bread.pptx
@@ -3212,12 +3212,20 @@
         </p:nvSpPr>
         <p:spPr>
           <a:xfrm>
-            <a:off x="731520" y="1645920"/>
-            <a:ext cx="4114800" cy="4389120"/>
+            <a:off x="731520" y="1463040"/>
+            <a:ext cx="4114800" cy="4754880"/>
           </a:xfrm>
+          <a:solidFill>
+            <a:srgbClr val="F8FAFC"/>
+          </a:solidFill>
+          <a:ln w="12700">
+            <a:solidFill>
+              <a:srgbClr val="CBD5E1"/>
+            </a:solidFill>
+          </a:ln>
         </p:spPr>
         <p:txBody>
-          <a:bodyPr/>
+          <a:bodyPr lIns="256032" rIns="256032" tIns="256032" bIns="256032" wrap="square"/>
           <a:lstStyle/>
           <a:p>
             <a:pPr>
@@ -3230,13 +3238,13 @@
               <a:buNone/>
             </a:pPr>
             <a:r>
-              <a:rPr lang="en-US" sz="1500" b="0">
-                <a:solidFill>
-                  <a:srgbClr val="334155"/>
+              <a:rPr lang="en-US" sz="1100" b="1">
+                <a:solidFill>
+                  <a:srgbClr val="0369A1"/>
                 </a:solidFill>
                 <a:latin typeface="Calibri"/>
               </a:rPr>
-              <a:t>The simplicity of this no-knead bread is what makes it a household favorite. Your entire home will fill with the aroma of fresh artisan bakery bread as it bakes.</a:t>
+              <a:t>OVERVIEW &amp; PHILOSOPHY</a:t>
             </a:r>
           </a:p>
           <a:p>
@@ -3250,7 +3258,27 @@
               <a:buNone/>
             </a:pPr>
             <a:r>
-              <a:rPr lang="en-US" sz="1500" b="0">
+              <a:rPr lang="en-US" sz="1350" b="0">
+                <a:solidFill>
+                  <a:srgbClr val="334155"/>
+                </a:solidFill>
+                <a:latin typeface="Calibri"/>
+              </a:rPr>
+              <a:t>The simplicity of this no-knead bread is what makes it a household favorite. Your entire home will fill with the aroma of fresh artisan bakery bread as it bakes.</a:t>
+            </a:r>
+          </a:p>
+          <a:p>
+            <a:pPr>
+              <a:spcBef>
+                <a:spcPts val="0"/>
+              </a:spcBef>
+              <a:spcAft>
+                <a:spcPts val="1200"/>
+              </a:spcAft>
+              <a:buNone/>
+            </a:pPr>
+            <a:r>
+              <a:rPr lang="en-US" sz="1350" b="0">
                 <a:solidFill>
                   <a:srgbClr val="334155"/>
                 </a:solidFill>
@@ -3270,7 +3298,7 @@
               <a:buNone/>
             </a:pPr>
             <a:r>
-              <a:rPr lang="en-US" sz="1500" b="0">
+              <a:rPr lang="en-US" sz="1350" b="0">
                 <a:solidFill>
                   <a:srgbClr val="334155"/>
                 </a:solidFill>
@@ -3297,8 +3325,8 @@
         </p:blipFill>
         <p:spPr>
           <a:xfrm>
-            <a:off x="5029200" y="1645920"/>
-            <a:ext cx="3474720" cy="2303890"/>
+            <a:off x="5120640" y="1463040"/>
+            <a:ext cx="3383280" cy="2243262"/>
           </a:xfrm>
           <a:prstGeom prst="rect">
             <a:avLst/>
@@ -3380,9 +3408,9 @@
                     <a:lstStyle/>
                     <a:p>
                       <a:r>
-                        <a:rPr lang="en-US" sz="1500" b="1">
+                        <a:rPr lang="en-US" sz="1400" b="1">
                           <a:solidFill>
-                            <a:srgbClr val="0F172A"/>
+                            <a:srgbClr val="FFFFFF"/>
                           </a:solidFill>
                           <a:latin typeface="Calibri"/>
                         </a:rPr>
@@ -3390,7 +3418,11 @@
                       </a:r>
                     </a:p>
                   </a:txBody>
-                  <a:tcPr/>
+                  <a:tcPr>
+                    <a:solidFill>
+                      <a:srgbClr val="0F172A"/>
+                    </a:solidFill>
+                  </a:tcPr>
                 </a:tc>
                 <a:tc>
                   <a:txBody>
@@ -3398,9 +3430,9 @@
                     <a:lstStyle/>
                     <a:p>
                       <a:r>
-                        <a:rPr lang="en-US" sz="1500" b="1">
+                        <a:rPr lang="en-US" sz="1400" b="1">
                           <a:solidFill>
-                            <a:srgbClr val="0F172A"/>
+                            <a:srgbClr val="FFFFFF"/>
                           </a:solidFill>
                           <a:latin typeface="Calibri"/>
                         </a:rPr>
@@ -3408,7 +3440,11 @@
                       </a:r>
                     </a:p>
                   </a:txBody>
-                  <a:tcPr/>
+                  <a:tcPr>
+                    <a:solidFill>
+                      <a:srgbClr val="0F172A"/>
+                    </a:solidFill>
+                  </a:tcPr>
                 </a:tc>
                 <a:tc>
                   <a:txBody>
@@ -3416,9 +3452,9 @@
                     <a:lstStyle/>
                     <a:p>
                       <a:r>
-                        <a:rPr lang="en-US" sz="1500" b="1">
+                        <a:rPr lang="en-US" sz="1400" b="1">
                           <a:solidFill>
-                            <a:srgbClr val="0F172A"/>
+                            <a:srgbClr val="FFFFFF"/>
                           </a:solidFill>
                           <a:latin typeface="Calibri"/>
                         </a:rPr>
@@ -3426,7 +3462,11 @@
                       </a:r>
                     </a:p>
                   </a:txBody>
-                  <a:tcPr/>
+                  <a:tcPr>
+                    <a:solidFill>
+                      <a:srgbClr val="0F172A"/>
+                    </a:solidFill>
+                  </a:tcPr>
                 </a:tc>
               </a:tr>
               <a:tr h="585216">
@@ -3436,7 +3476,7 @@
                     <a:lstStyle/>
                     <a:p>
                       <a:r>
-                        <a:rPr lang="en-US" sz="1400" b="0">
+                        <a:rPr lang="en-US" sz="1350" b="0">
                           <a:solidFill>
                             <a:srgbClr val="334155"/>
                           </a:solidFill>
@@ -3446,7 +3486,11 @@
                       </a:r>
                     </a:p>
                   </a:txBody>
-                  <a:tcPr/>
+                  <a:tcPr>
+                    <a:solidFill>
+                      <a:srgbClr val="F8FAFC"/>
+                    </a:solidFill>
+                  </a:tcPr>
                 </a:tc>
                 <a:tc>
                   <a:txBody>
@@ -3454,7 +3498,7 @@
                     <a:lstStyle/>
                     <a:p>
                       <a:r>
-                        <a:rPr lang="en-US" sz="1400" b="0">
+                        <a:rPr lang="en-US" sz="1350" b="0">
                           <a:solidFill>
                             <a:srgbClr val="334155"/>
                           </a:solidFill>
@@ -3464,7 +3508,11 @@
                       </a:r>
                     </a:p>
                   </a:txBody>
-                  <a:tcPr/>
+                  <a:tcPr>
+                    <a:solidFill>
+                      <a:srgbClr val="F8FAFC"/>
+                    </a:solidFill>
+                  </a:tcPr>
                 </a:tc>
                 <a:tc>
                   <a:txBody>
@@ -3472,7 +3520,7 @@
                     <a:lstStyle/>
                     <a:p>
                       <a:r>
-                        <a:rPr lang="en-US" sz="1400" b="0">
+                        <a:rPr lang="en-US" sz="1350" b="0">
                           <a:solidFill>
                             <a:srgbClr val="334155"/>
                           </a:solidFill>
@@ -3482,7 +3530,11 @@
                       </a:r>
                     </a:p>
                   </a:txBody>
-                  <a:tcPr/>
+                  <a:tcPr>
+                    <a:solidFill>
+                      <a:srgbClr val="F8FAFC"/>
+                    </a:solidFill>
+                  </a:tcPr>
                 </a:tc>
               </a:tr>
               <a:tr h="585216">
@@ -3492,7 +3544,7 @@
                     <a:lstStyle/>
                     <a:p>
                       <a:r>
-                        <a:rPr lang="en-US" sz="1400" b="0">
+                        <a:rPr lang="en-US" sz="1350" b="0">
                           <a:solidFill>
                             <a:srgbClr val="334155"/>
                           </a:solidFill>
@@ -3502,7 +3554,11 @@
                       </a:r>
                     </a:p>
                   </a:txBody>
-                  <a:tcPr/>
+                  <a:tcPr>
+                    <a:solidFill>
+                      <a:srgbClr val="FFFFFF"/>
+                    </a:solidFill>
+                  </a:tcPr>
                 </a:tc>
                 <a:tc>
                   <a:txBody>
@@ -3510,7 +3566,7 @@
                     <a:lstStyle/>
                     <a:p>
                       <a:r>
-                        <a:rPr lang="en-US" sz="1400" b="0">
+                        <a:rPr lang="en-US" sz="1350" b="0">
                           <a:solidFill>
                             <a:srgbClr val="334155"/>
                           </a:solidFill>
@@ -3520,7 +3576,11 @@
                       </a:r>
                     </a:p>
                   </a:txBody>
-                  <a:tcPr/>
+                  <a:tcPr>
+                    <a:solidFill>
+                      <a:srgbClr val="FFFFFF"/>
+                    </a:solidFill>
+                  </a:tcPr>
                 </a:tc>
                 <a:tc>
                   <a:txBody>
@@ -3528,7 +3588,7 @@
                     <a:lstStyle/>
                     <a:p>
                       <a:r>
-                        <a:rPr lang="en-US" sz="1400" b="0">
+                        <a:rPr lang="en-US" sz="1350" b="0">
                           <a:solidFill>
                             <a:srgbClr val="334155"/>
                           </a:solidFill>
@@ -3538,7 +3598,11 @@
                       </a:r>
                     </a:p>
                   </a:txBody>
-                  <a:tcPr/>
+                  <a:tcPr>
+                    <a:solidFill>
+                      <a:srgbClr val="FFFFFF"/>
+                    </a:solidFill>
+                  </a:tcPr>
                 </a:tc>
               </a:tr>
               <a:tr h="585216">
@@ -3548,7 +3612,7 @@
                     <a:lstStyle/>
                     <a:p>
                       <a:r>
-                        <a:rPr lang="en-US" sz="1400" b="0">
+                        <a:rPr lang="en-US" sz="1350" b="0">
                           <a:solidFill>
                             <a:srgbClr val="334155"/>
                           </a:solidFill>
@@ -3558,7 +3622,11 @@
                       </a:r>
                     </a:p>
                   </a:txBody>
-                  <a:tcPr/>
+                  <a:tcPr>
+                    <a:solidFill>
+                      <a:srgbClr val="F8FAFC"/>
+                    </a:solidFill>
+                  </a:tcPr>
                 </a:tc>
                 <a:tc>
                   <a:txBody>
@@ -3566,7 +3634,7 @@
                     <a:lstStyle/>
                     <a:p>
                       <a:r>
-                        <a:rPr lang="en-US" sz="1400" b="0">
+                        <a:rPr lang="en-US" sz="1350" b="0">
                           <a:solidFill>
                             <a:srgbClr val="334155"/>
                           </a:solidFill>
@@ -3576,7 +3644,11 @@
                       </a:r>
                     </a:p>
                   </a:txBody>
-                  <a:tcPr/>
+                  <a:tcPr>
+                    <a:solidFill>
+                      <a:srgbClr val="F8FAFC"/>
+                    </a:solidFill>
+                  </a:tcPr>
                 </a:tc>
                 <a:tc>
                   <a:txBody>
@@ -3584,7 +3656,7 @@
                     <a:lstStyle/>
                     <a:p>
                       <a:r>
-                        <a:rPr lang="en-US" sz="1400" b="0">
+                        <a:rPr lang="en-US" sz="1350" b="0">
                           <a:solidFill>
                             <a:srgbClr val="334155"/>
                           </a:solidFill>
@@ -3594,7 +3666,11 @@
                       </a:r>
                     </a:p>
                   </a:txBody>
-                  <a:tcPr/>
+                  <a:tcPr>
+                    <a:solidFill>
+                      <a:srgbClr val="F8FAFC"/>
+                    </a:solidFill>
+                  </a:tcPr>
                 </a:tc>
               </a:tr>
               <a:tr h="585216">
@@ -3604,7 +3680,7 @@
                     <a:lstStyle/>
                     <a:p>
                       <a:r>
-                        <a:rPr lang="en-US" sz="1400" b="0">
+                        <a:rPr lang="en-US" sz="1350" b="0">
                           <a:solidFill>
                             <a:srgbClr val="334155"/>
                           </a:solidFill>
@@ -3614,7 +3690,11 @@
                       </a:r>
                     </a:p>
                   </a:txBody>
-                  <a:tcPr/>
+                  <a:tcPr>
+                    <a:solidFill>
+                      <a:srgbClr val="FFFFFF"/>
+                    </a:solidFill>
+                  </a:tcPr>
                 </a:tc>
                 <a:tc>
                   <a:txBody>
@@ -3622,7 +3702,7 @@
                     <a:lstStyle/>
                     <a:p>
                       <a:r>
-                        <a:rPr lang="en-US" sz="1400" b="0">
+                        <a:rPr lang="en-US" sz="1350" b="0">
                           <a:solidFill>
                             <a:srgbClr val="334155"/>
                           </a:solidFill>
@@ -3632,7 +3712,11 @@
                       </a:r>
                     </a:p>
                   </a:txBody>
-                  <a:tcPr/>
+                  <a:tcPr>
+                    <a:solidFill>
+                      <a:srgbClr val="FFFFFF"/>
+                    </a:solidFill>
+                  </a:tcPr>
                 </a:tc>
                 <a:tc>
                   <a:txBody>
@@ -3640,7 +3724,7 @@
                     <a:lstStyle/>
                     <a:p>
                       <a:r>
-                        <a:rPr lang="en-US" sz="1400" b="0">
+                        <a:rPr lang="en-US" sz="1350" b="0">
                           <a:solidFill>
                             <a:srgbClr val="334155"/>
                           </a:solidFill>
@@ -3650,7 +3734,11 @@
                       </a:r>
                     </a:p>
                   </a:txBody>
-                  <a:tcPr/>
+                  <a:tcPr>
+                    <a:solidFill>
+                      <a:srgbClr val="FFFFFF"/>
+                    </a:solidFill>
+                  </a:tcPr>
                 </a:tc>
               </a:tr>
             </a:tbl>
@@ -3709,17 +3797,25 @@
             <a:spLocks noGrp="1"/>
           </p:cNvSpPr>
           <p:nvPr>
-            <p:ph idx="1"/>
+            <p:ph idx="1" sz="half"/>
           </p:nvPr>
         </p:nvSpPr>
         <p:spPr>
           <a:xfrm>
-            <a:off x="0" y="1645920"/>
-            <a:ext cx="0" cy="4572000"/>
+            <a:off x="731520" y="1463040"/>
+            <a:ext cx="3657600" cy="4754880"/>
           </a:xfrm>
+          <a:solidFill>
+            <a:srgbClr val="F8FAFC"/>
+          </a:solidFill>
+          <a:ln w="12700">
+            <a:solidFill>
+              <a:srgbClr val="CBD5E1"/>
+            </a:solidFill>
+          </a:ln>
         </p:spPr>
         <p:txBody>
-          <a:bodyPr/>
+          <a:bodyPr lIns="256032" rIns="256032" tIns="256032" bIns="256032" wrap="square"/>
           <a:lstStyle/>
           <a:p>
             <a:pPr>
@@ -3727,18 +3823,18 @@
                 <a:spcPts val="0"/>
               </a:spcBef>
               <a:spcAft>
-                <a:spcPts val="600"/>
+                <a:spcPts val="1200"/>
               </a:spcAft>
               <a:buNone/>
             </a:pPr>
             <a:r>
-              <a:rPr lang="en-US" sz="1400" b="0">
-                <a:solidFill>
-                  <a:srgbClr val="334155"/>
+              <a:rPr lang="en-US" sz="1100" b="1">
+                <a:solidFill>
+                  <a:srgbClr val="0369A1"/>
                 </a:solidFill>
                 <a:latin typeface="Calibri"/>
               </a:rPr>
-              <a:t>1. In a large bowl, whisk together flour, salt, and yeast.</a:t>
+              <a:t>PHASE 1: PREPARATION &amp; FERMENT</a:t>
             </a:r>
           </a:p>
           <a:p>
@@ -3747,18 +3843,18 @@
                 <a:spcPts val="0"/>
               </a:spcBef>
               <a:spcAft>
-                <a:spcPts val="600"/>
+                <a:spcPts val="200"/>
               </a:spcAft>
               <a:buNone/>
             </a:pPr>
             <a:r>
-              <a:rPr lang="en-US" sz="1400" b="0">
-                <a:solidFill>
-                  <a:srgbClr val="334155"/>
+              <a:rPr lang="en-US" sz="1350" b="1">
+                <a:solidFill>
+                  <a:srgbClr val="0F172A"/>
                 </a:solidFill>
                 <a:latin typeface="Calibri"/>
               </a:rPr>
-              <a:t>2. Add room-temperature water; stir with a wooden spoon until a shaggy dough forms.</a:t>
+              <a:t>01  Whisk Dry Ingredients</a:t>
             </a:r>
           </a:p>
           <a:p>
@@ -3767,18 +3863,18 @@
                 <a:spcPts val="0"/>
               </a:spcBef>
               <a:spcAft>
-                <a:spcPts val="600"/>
+                <a:spcPts val="1000"/>
               </a:spcAft>
               <a:buNone/>
             </a:pPr>
             <a:r>
-              <a:rPr lang="en-US" sz="1400" b="0">
+              <a:rPr lang="en-US" sz="1200" b="0">
                 <a:solidFill>
                   <a:srgbClr val="334155"/>
                 </a:solidFill>
                 <a:latin typeface="Calibri"/>
               </a:rPr>
-              <a:t>3. Cover tightly with plastic wrap; let rest at room temperature for 12 to 18 hours.</a:t>
+              <a:t>In a large mixing bowl, whisk together 3 cups all-purpose flour, 1¾ tsp salt, and ½ tsp active dry yeast.</a:t>
             </a:r>
           </a:p>
           <a:p>
@@ -3787,18 +3883,18 @@
                 <a:spcPts val="0"/>
               </a:spcBef>
               <a:spcAft>
-                <a:spcPts val="600"/>
+                <a:spcPts val="200"/>
               </a:spcAft>
               <a:buNone/>
             </a:pPr>
             <a:r>
-              <a:rPr lang="en-US" sz="1400" b="0">
-                <a:solidFill>
-                  <a:srgbClr val="334155"/>
+              <a:rPr lang="en-US" sz="1350" b="1">
+                <a:solidFill>
+                  <a:srgbClr val="0F172A"/>
                 </a:solidFill>
                 <a:latin typeface="Calibri"/>
               </a:rPr>
-              <a:t>4. Preheat oven and covered cast iron Dutch oven to 450°F (230°C).</a:t>
+              <a:t>02  Form Shaggy Dough</a:t>
             </a:r>
           </a:p>
           <a:p>
@@ -3807,18 +3903,18 @@
                 <a:spcPts val="0"/>
               </a:spcBef>
               <a:spcAft>
-                <a:spcPts val="600"/>
+                <a:spcPts val="1000"/>
               </a:spcAft>
               <a:buNone/>
             </a:pPr>
             <a:r>
-              <a:rPr lang="en-US" sz="1400" b="0">
+              <a:rPr lang="en-US" sz="1200" b="0">
                 <a:solidFill>
                   <a:srgbClr val="334155"/>
                 </a:solidFill>
                 <a:latin typeface="Calibri"/>
               </a:rPr>
-              <a:t>5. Gently turn dough onto a floured surface, shape into a ball, and transfer to hot pot.</a:t>
+              <a:t>Pour in 1½ cups room-temperature water. Mix with a spatula or wooden spoon until thoroughly incorporated.</a:t>
             </a:r>
           </a:p>
           <a:p>
@@ -3827,18 +3923,207 @@
                 <a:spcPts val="0"/>
               </a:spcBef>
               <a:spcAft>
-                <a:spcPts val="600"/>
+                <a:spcPts val="200"/>
               </a:spcAft>
               <a:buNone/>
             </a:pPr>
             <a:r>
-              <a:rPr lang="en-US" sz="1400" b="0">
-                <a:solidFill>
-                  <a:srgbClr val="334155"/>
+              <a:rPr lang="en-US" sz="1350" b="1">
+                <a:solidFill>
+                  <a:srgbClr val="0F172A"/>
                 </a:solidFill>
                 <a:latin typeface="Calibri"/>
               </a:rPr>
-              <a:t>6. Bake covered for 30 minutes, then uncovered for 15 to 20 minutes until golden brown.</a:t>
+              <a:t>03  Overnight Counter Rest</a:t>
+            </a:r>
+          </a:p>
+          <a:p>
+            <a:pPr>
+              <a:spcBef>
+                <a:spcPts val="0"/>
+              </a:spcBef>
+              <a:spcAft>
+                <a:spcPts val="0"/>
+              </a:spcAft>
+              <a:buNone/>
+            </a:pPr>
+            <a:r>
+              <a:rPr lang="en-US" sz="1200" b="0">
+                <a:solidFill>
+                  <a:srgbClr val="334155"/>
+                </a:solidFill>
+                <a:latin typeface="Calibri"/>
+              </a:rPr>
+              <a:t>Cover bowl tightly with plastic wrap. Let rest at room temperature for 12 to 18 hours until bubbly and doubled.</a:t>
+            </a:r>
+          </a:p>
+        </p:txBody>
+      </p:sp>
+      <p:sp>
+        <p:nvSpPr>
+          <p:cNvPr id="4" name="Content Placeholder 3"/>
+          <p:cNvSpPr>
+            <a:spLocks noGrp="1"/>
+          </p:cNvSpPr>
+          <p:nvPr>
+            <p:ph idx="2" sz="half"/>
+          </p:nvPr>
+        </p:nvSpPr>
+        <p:spPr>
+          <a:xfrm>
+            <a:off x="4754880" y="1463040"/>
+            <a:ext cx="3657600" cy="4754880"/>
+          </a:xfrm>
+          <a:solidFill>
+            <a:srgbClr val="F8FAFC"/>
+          </a:solidFill>
+          <a:ln w="12700">
+            <a:solidFill>
+              <a:srgbClr val="CBD5E1"/>
+            </a:solidFill>
+          </a:ln>
+        </p:spPr>
+        <p:txBody>
+          <a:bodyPr lIns="256032" rIns="256032" tIns="256032" bIns="256032" wrap="square"/>
+          <a:lstStyle/>
+          <a:p>
+            <a:pPr>
+              <a:spcBef>
+                <a:spcPts val="0"/>
+              </a:spcBef>
+              <a:spcAft>
+                <a:spcPts val="1200"/>
+              </a:spcAft>
+              <a:buNone/>
+            </a:pPr>
+            <a:r>
+              <a:rPr lang="en-US" sz="1100" b="1">
+                <a:solidFill>
+                  <a:srgbClr val="0369A1"/>
+                </a:solidFill>
+                <a:latin typeface="Calibri"/>
+              </a:rPr>
+              <a:t>PHASE 2: PREHEAT &amp; BAKE</a:t>
+            </a:r>
+          </a:p>
+          <a:p>
+            <a:pPr>
+              <a:spcBef>
+                <a:spcPts val="0"/>
+              </a:spcBef>
+              <a:spcAft>
+                <a:spcPts val="200"/>
+              </a:spcAft>
+              <a:buNone/>
+            </a:pPr>
+            <a:r>
+              <a:rPr lang="en-US" sz="1350" b="1">
+                <a:solidFill>
+                  <a:srgbClr val="0F172A"/>
+                </a:solidFill>
+                <a:latin typeface="Calibri"/>
+              </a:rPr>
+              <a:t>04  Preheat Oven &amp; Dutch Oven</a:t>
+            </a:r>
+          </a:p>
+          <a:p>
+            <a:pPr>
+              <a:spcBef>
+                <a:spcPts val="0"/>
+              </a:spcBef>
+              <a:spcAft>
+                <a:spcPts val="1000"/>
+              </a:spcAft>
+              <a:buNone/>
+            </a:pPr>
+            <a:r>
+              <a:rPr lang="en-US" sz="1200" b="0">
+                <a:solidFill>
+                  <a:srgbClr val="334155"/>
+                </a:solidFill>
+                <a:latin typeface="Calibri"/>
+              </a:rPr>
+              <a:t>Place covered cast iron Dutch oven inside oven. Preheat both together to 450°F (230°C) for at least 30 minutes.</a:t>
+            </a:r>
+          </a:p>
+          <a:p>
+            <a:pPr>
+              <a:spcBef>
+                <a:spcPts val="0"/>
+              </a:spcBef>
+              <a:spcAft>
+                <a:spcPts val="200"/>
+              </a:spcAft>
+              <a:buNone/>
+            </a:pPr>
+            <a:r>
+              <a:rPr lang="en-US" sz="1350" b="1">
+                <a:solidFill>
+                  <a:srgbClr val="0F172A"/>
+                </a:solidFill>
+                <a:latin typeface="Calibri"/>
+              </a:rPr>
+              <a:t>05  Shape &amp; Transfer Dough</a:t>
+            </a:r>
+          </a:p>
+          <a:p>
+            <a:pPr>
+              <a:spcBef>
+                <a:spcPts val="0"/>
+              </a:spcBef>
+              <a:spcAft>
+                <a:spcPts val="1000"/>
+              </a:spcAft>
+              <a:buNone/>
+            </a:pPr>
+            <a:r>
+              <a:rPr lang="en-US" sz="1200" b="0">
+                <a:solidFill>
+                  <a:srgbClr val="334155"/>
+                </a:solidFill>
+                <a:latin typeface="Calibri"/>
+              </a:rPr>
+              <a:t>With floured hands, gently turn dough onto a floured counter, shape into a ball, and drop into hot pot.</a:t>
+            </a:r>
+          </a:p>
+          <a:p>
+            <a:pPr>
+              <a:spcBef>
+                <a:spcPts val="0"/>
+              </a:spcBef>
+              <a:spcAft>
+                <a:spcPts val="200"/>
+              </a:spcAft>
+              <a:buNone/>
+            </a:pPr>
+            <a:r>
+              <a:rPr lang="en-US" sz="1350" b="1">
+                <a:solidFill>
+                  <a:srgbClr val="0F172A"/>
+                </a:solidFill>
+                <a:latin typeface="Calibri"/>
+              </a:rPr>
+              <a:t>06  Covered &amp; Uncovered Bake</a:t>
+            </a:r>
+          </a:p>
+          <a:p>
+            <a:pPr>
+              <a:spcBef>
+                <a:spcPts val="0"/>
+              </a:spcBef>
+              <a:spcAft>
+                <a:spcPts val="0"/>
+              </a:spcAft>
+              <a:buNone/>
+            </a:pPr>
+            <a:r>
+              <a:rPr lang="en-US" sz="1200" b="0">
+                <a:solidFill>
+                  <a:srgbClr val="334155"/>
+                </a:solidFill>
+                <a:latin typeface="Calibri"/>
+              </a:rPr>
+              <a:t>Bake covered 30 minutes to trap steam. Remove lid and bake 15–20 minutes more until crust is deeply golden.</a:t>
             </a:r>
           </a:p>
         </p:txBody>
@@ -3895,17 +4180,25 @@
             <a:spLocks noGrp="1"/>
           </p:cNvSpPr>
           <p:nvPr>
-            <p:ph idx="1"/>
+            <p:ph idx="1" sz="half"/>
           </p:nvPr>
         </p:nvSpPr>
         <p:spPr>
           <a:xfrm>
-            <a:off x="0" y="1645920"/>
-            <a:ext cx="0" cy="4389120"/>
+            <a:off x="731520" y="1463040"/>
+            <a:ext cx="3657600" cy="4754880"/>
           </a:xfrm>
+          <a:solidFill>
+            <a:srgbClr val="F8FAFC"/>
+          </a:solidFill>
+          <a:ln w="12700">
+            <a:solidFill>
+              <a:srgbClr val="CBD5E1"/>
+            </a:solidFill>
+          </a:ln>
         </p:spPr>
         <p:txBody>
-          <a:bodyPr/>
+          <a:bodyPr lIns="256032" rIns="256032" tIns="256032" bIns="256032" wrap="square"/>
           <a:lstStyle/>
           <a:p>
             <a:pPr>
@@ -3913,27 +4206,18 @@
                 <a:spcPts val="0"/>
               </a:spcBef>
               <a:spcAft>
-                <a:spcPts val="1000"/>
+                <a:spcPts val="1400"/>
               </a:spcAft>
               <a:buNone/>
             </a:pPr>
             <a:r>
-              <a:rPr lang="en-US" sz="1500" b="1">
-                <a:solidFill>
-                  <a:srgbClr val="0F172A"/>
+              <a:rPr lang="en-US" sz="1100" b="1">
+                <a:solidFill>
+                  <a:srgbClr val="0369A1"/>
                 </a:solidFill>
                 <a:latin typeface="Calibri"/>
               </a:rPr>
-              <a:t>Cool Completely: </a:t>
-            </a:r>
-            <a:r>
-              <a:rPr lang="en-US" sz="1500" b="0">
-                <a:solidFill>
-                  <a:srgbClr val="334155"/>
-                </a:solidFill>
-                <a:latin typeface="Calibri"/>
-              </a:rPr>
-              <a:t>Allow loaf to rest on a wire cooling rack for at least 1 hour before slicing to prevent gumminess.</a:t>
+              <a:t>HANDLING &amp; STORAGE PROTOCOL</a:t>
             </a:r>
           </a:p>
           <a:p>
@@ -3942,27 +4226,18 @@
                 <a:spcPts val="0"/>
               </a:spcBef>
               <a:spcAft>
-                <a:spcPts val="1000"/>
+                <a:spcPts val="300"/>
               </a:spcAft>
               <a:buNone/>
             </a:pPr>
             <a:r>
-              <a:rPr lang="en-US" sz="1500" b="1">
+              <a:rPr lang="en-US" sz="1350" b="1">
                 <a:solidFill>
                   <a:srgbClr val="0F172A"/>
                 </a:solidFill>
                 <a:latin typeface="Calibri"/>
               </a:rPr>
-              <a:t>Storage: </a:t>
-            </a:r>
-            <a:r>
-              <a:rPr lang="en-US" sz="1500" b="0">
-                <a:solidFill>
-                  <a:srgbClr val="334155"/>
-                </a:solidFill>
-                <a:latin typeface="Calibri"/>
-              </a:rPr>
-              <a:t>Store at room temperature in a paper bag or bread box for up to 3 days. Avoid plastic bags.</a:t>
+              <a:t>Cool Completely Before Slicing</a:t>
             </a:r>
           </a:p>
           <a:p>
@@ -3971,45 +4246,208 @@
                 <a:spcPts val="0"/>
               </a:spcBef>
               <a:spcAft>
-                <a:spcPts val="1000"/>
+                <a:spcPts val="1600"/>
               </a:spcAft>
               <a:buNone/>
             </a:pPr>
             <a:r>
-              <a:rPr lang="en-US" sz="1500" b="1">
-                <a:solidFill>
-                  <a:srgbClr val="0F172A"/>
+              <a:rPr lang="en-US" sz="1250" b="0">
+                <a:solidFill>
+                  <a:srgbClr val="334155"/>
                 </a:solidFill>
                 <a:latin typeface="Calibri"/>
               </a:rPr>
-              <a:t>Serving: </a:t>
-            </a:r>
-            <a:r>
-              <a:rPr lang="en-US" sz="1500" b="0">
-                <a:solidFill>
-                  <a:srgbClr val="334155"/>
+              <a:t>Allow loaf to rest on a wire cooling rack for at least 1 full hour. Slicing warm bread compresses steam and creates a gummy, dense crumb.</a:t>
+            </a:r>
+          </a:p>
+          <a:p>
+            <a:pPr>
+              <a:spcBef>
+                <a:spcPts val="0"/>
+              </a:spcBef>
+              <a:spcAft>
+                <a:spcPts val="300"/>
+              </a:spcAft>
+              <a:buNone/>
+            </a:pPr>
+            <a:r>
+              <a:rPr lang="en-US" sz="1350" b="1">
+                <a:solidFill>
+                  <a:srgbClr val="0F172A"/>
                 </a:solidFill>
                 <a:latin typeface="Calibri"/>
               </a:rPr>
-              <a:t>Perfect warm with salted European butter, extra virgin olive oil, or hearty soups.</a:t>
+              <a:t>Preserve the Crust (No Plastic)</a:t>
             </a:r>
           </a:p>
           <a:p>
             <a:pPr>
               <a:spcBef>
-                <a:spcPts val="800"/>
+                <a:spcPts val="0"/>
               </a:spcBef>
+              <a:spcAft>
+                <a:spcPts val="0"/>
+              </a:spcAft>
               <a:buNone/>
             </a:pPr>
             <a:r>
-              <a:rPr lang="en-US" sz="1500" b="1">
-                <a:solidFill>
-                  <a:srgbClr val="0284C7"/>
+              <a:rPr lang="en-US" sz="1250" b="0">
+                <a:solidFill>
+                  <a:srgbClr val="334155"/>
+                </a:solidFill>
+                <a:latin typeface="Calibri"/>
+              </a:rPr>
+              <a:t>Store cut-side down in a breathable paper bag or wooden bread box at room temperature for up to 3 days. Avoid plastic bags, which trap moisture and soften the crust.</a:t>
+            </a:r>
+          </a:p>
+        </p:txBody>
+      </p:sp>
+      <p:sp>
+        <p:nvSpPr>
+          <p:cNvPr id="4" name="Content Placeholder 3"/>
+          <p:cNvSpPr>
+            <a:spLocks noGrp="1"/>
+          </p:cNvSpPr>
+          <p:nvPr>
+            <p:ph idx="2" sz="half"/>
+          </p:nvPr>
+        </p:nvSpPr>
+        <p:spPr>
+          <a:xfrm>
+            <a:off x="4754880" y="1463040"/>
+            <a:ext cx="3657600" cy="4754880"/>
+          </a:xfrm>
+          <a:solidFill>
+            <a:srgbClr val="F8FAFC"/>
+          </a:solidFill>
+          <a:ln w="12700">
+            <a:solidFill>
+              <a:srgbClr val="CBD5E1"/>
+            </a:solidFill>
+          </a:ln>
+        </p:spPr>
+        <p:txBody>
+          <a:bodyPr lIns="256032" rIns="256032" tIns="256032" bIns="256032" wrap="square"/>
+          <a:lstStyle/>
+          <a:p>
+            <a:pPr>
+              <a:spcBef>
+                <a:spcPts val="0"/>
+              </a:spcBef>
+              <a:spcAft>
+                <a:spcPts val="1400"/>
+              </a:spcAft>
+              <a:buNone/>
+            </a:pPr>
+            <a:r>
+              <a:rPr lang="en-US" sz="1100" b="1">
+                <a:solidFill>
+                  <a:srgbClr val="0369A1"/>
+                </a:solidFill>
+                <a:latin typeface="Calibri"/>
+              </a:rPr>
+              <a:t>SERVING IDEAS &amp; RESOURCES</a:t>
+            </a:r>
+          </a:p>
+          <a:p>
+            <a:pPr>
+              <a:spcBef>
+                <a:spcPts val="0"/>
+              </a:spcBef>
+              <a:spcAft>
+                <a:spcPts val="300"/>
+              </a:spcAft>
+              <a:buNone/>
+            </a:pPr>
+            <a:r>
+              <a:rPr lang="en-US" sz="1350" b="1">
+                <a:solidFill>
+                  <a:srgbClr val="0F172A"/>
+                </a:solidFill>
+                <a:latin typeface="Calibri"/>
+              </a:rPr>
+              <a:t>Pairing &amp; Serving Ideas</a:t>
+            </a:r>
+          </a:p>
+          <a:p>
+            <a:pPr>
+              <a:spcBef>
+                <a:spcPts val="0"/>
+              </a:spcBef>
+              <a:spcAft>
+                <a:spcPts val="1600"/>
+              </a:spcAft>
+              <a:buNone/>
+            </a:pPr>
+            <a:r>
+              <a:rPr lang="en-US" sz="1250" b="0">
+                <a:solidFill>
+                  <a:srgbClr val="334155"/>
+                </a:solidFill>
+                <a:latin typeface="Calibri"/>
+              </a:rPr>
+              <a:t>Slice thick and serve warm with salted European cultured butter, extra virgin olive oil with flaky sea salt, artisan cheeses, or dipping into hearty soups.</a:t>
+            </a:r>
+          </a:p>
+          <a:p>
+            <a:pPr>
+              <a:spcBef>
+                <a:spcPts val="0"/>
+              </a:spcBef>
+              <a:spcAft>
+                <a:spcPts val="300"/>
+              </a:spcAft>
+              <a:buNone/>
+            </a:pPr>
+            <a:r>
+              <a:rPr lang="en-US" sz="1350" b="1">
+                <a:solidFill>
+                  <a:srgbClr val="0F172A"/>
+                </a:solidFill>
+                <a:latin typeface="Calibri"/>
+              </a:rPr>
+              <a:t>Baker's Companion Guide</a:t>
+            </a:r>
+          </a:p>
+          <a:p>
+            <a:pPr>
+              <a:spcBef>
+                <a:spcPts val="0"/>
+              </a:spcBef>
+              <a:spcAft>
+                <a:spcPts val="600"/>
+              </a:spcAft>
+              <a:buNone/>
+            </a:pPr>
+            <a:r>
+              <a:rPr lang="en-US" sz="1250" b="0">
+                <a:solidFill>
+                  <a:srgbClr val="334155"/>
+                </a:solidFill>
+                <a:latin typeface="Calibri"/>
+              </a:rPr>
+              <a:t>Looking for hydration ratios, whole wheat variations, and troubleshooting tips?</a:t>
+            </a:r>
+          </a:p>
+          <a:p>
+            <a:pPr>
+              <a:spcBef>
+                <a:spcPts val="0"/>
+              </a:spcBef>
+              <a:spcAft>
+                <a:spcPts val="0"/>
+              </a:spcAft>
+              <a:buNone/>
+            </a:pPr>
+            <a:r>
+              <a:rPr lang="en-US" sz="1250" b="1">
+                <a:solidFill>
+                  <a:srgbClr val="0369A1"/>
                 </a:solidFill>
                 <a:latin typeface="Calibri"/>
                 <a:hlinkClick r:id="rId2"/>
               </a:rPr>
-              <a:t>Explore the complete Artisan Dutch Oven Baking Guide</a:t>
+              <a:t>Explore the Complete Artisan Dutch Oven Guide</a:t>
             </a:r>
           </a:p>
         </p:txBody>

</xml_diff>

<commit_message>
feat(examples): add semantic OpenXML numbered list to Slide 4 and bullet list to Slide 5
</commit_message>
<xml_diff>
--- a/examples/No Knead Bread.pptx
+++ b/examples/No Knead Bread.pptx
@@ -3797,13 +3797,13 @@
             <a:spLocks noGrp="1"/>
           </p:cNvSpPr>
           <p:nvPr>
-            <p:ph idx="1" sz="half"/>
+            <p:ph idx="1"/>
           </p:nvPr>
         </p:nvSpPr>
         <p:spPr>
           <a:xfrm>
             <a:off x="731520" y="1463040"/>
-            <a:ext cx="3657600" cy="4754880"/>
+            <a:ext cx="7680960" cy="4754880"/>
           </a:xfrm>
           <a:solidFill>
             <a:srgbClr val="F8FAFC"/>
@@ -3818,283 +3818,130 @@
           <a:bodyPr lIns="256032" rIns="256032" tIns="256032" bIns="256032" wrap="square"/>
           <a:lstStyle/>
           <a:p>
-            <a:pPr>
-              <a:spcBef>
-                <a:spcPts val="0"/>
-              </a:spcBef>
-              <a:spcAft>
-                <a:spcPts val="1200"/>
-              </a:spcAft>
-              <a:buNone/>
-            </a:pPr>
-            <a:r>
-              <a:rPr lang="en-US" sz="1100" b="1">
-                <a:solidFill>
-                  <a:srgbClr val="0369A1"/>
-                </a:solidFill>
-                <a:latin typeface="Calibri"/>
-              </a:rPr>
-              <a:t>PHASE 1: PREPARATION &amp; FERMENT</a:t>
-            </a:r>
-          </a:p>
-          <a:p>
-            <a:pPr>
-              <a:spcBef>
-                <a:spcPts val="0"/>
-              </a:spcBef>
-              <a:spcAft>
-                <a:spcPts val="200"/>
-              </a:spcAft>
-              <a:buNone/>
-            </a:pPr>
-            <a:r>
-              <a:rPr lang="en-US" sz="1350" b="1">
-                <a:solidFill>
-                  <a:srgbClr val="0F172A"/>
-                </a:solidFill>
-                <a:latin typeface="Calibri"/>
-              </a:rPr>
-              <a:t>01  Whisk Dry Ingredients</a:t>
-            </a:r>
-          </a:p>
-          <a:p>
-            <a:pPr>
+            <a:pPr marL="342900" indent="-342900">
               <a:spcBef>
                 <a:spcPts val="0"/>
               </a:spcBef>
               <a:spcAft>
                 <a:spcPts val="1000"/>
               </a:spcAft>
-              <a:buNone/>
+              <a:buAutoNum type="arabicPeriod"/>
             </a:pPr>
             <a:r>
-              <a:rPr lang="en-US" sz="1200" b="0">
-                <a:solidFill>
-                  <a:srgbClr val="334155"/>
+              <a:rPr lang="en-US" sz="1350" b="1">
+                <a:solidFill>
+                  <a:srgbClr val="0F172A"/>
                 </a:solidFill>
                 <a:latin typeface="Calibri"/>
               </a:rPr>
-              <a:t>In a large mixing bowl, whisk together 3 cups all-purpose flour, 1¾ tsp salt, and ½ tsp active dry yeast.</a:t>
-            </a:r>
-          </a:p>
-          <a:p>
-            <a:pPr>
-              <a:spcBef>
-                <a:spcPts val="0"/>
-              </a:spcBef>
-              <a:spcAft>
-                <a:spcPts val="200"/>
-              </a:spcAft>
-              <a:buNone/>
-            </a:pPr>
-            <a:r>
-              <a:rPr lang="en-US" sz="1350" b="1">
-                <a:solidFill>
-                  <a:srgbClr val="0F172A"/>
+              <a:t>Whisk Dry Ingredients — </a:t>
+            </a:r>
+            <a:r>
+              <a:rPr lang="en-US" sz="1300" b="0">
+                <a:solidFill>
+                  <a:srgbClr val="334155"/>
                 </a:solidFill>
                 <a:latin typeface="Calibri"/>
               </a:rPr>
-              <a:t>02  Form Shaggy Dough</a:t>
-            </a:r>
-          </a:p>
-          <a:p>
-            <a:pPr>
+              <a:t>In a large bowl, whisk together 3 cups all-purpose flour, 1¾ tsp fine salt, and ½ tsp active dry yeast.</a:t>
+            </a:r>
+          </a:p>
+          <a:p>
+            <a:pPr marL="342900" indent="-342900">
               <a:spcBef>
                 <a:spcPts val="0"/>
               </a:spcBef>
               <a:spcAft>
                 <a:spcPts val="1000"/>
               </a:spcAft>
-              <a:buNone/>
+              <a:buAutoNum type="arabicPeriod"/>
             </a:pPr>
             <a:r>
-              <a:rPr lang="en-US" sz="1200" b="0">
-                <a:solidFill>
-                  <a:srgbClr val="334155"/>
+              <a:rPr lang="en-US" sz="1350" b="1">
+                <a:solidFill>
+                  <a:srgbClr val="0F172A"/>
                 </a:solidFill>
                 <a:latin typeface="Calibri"/>
               </a:rPr>
-              <a:t>Pour in 1½ cups room-temperature water. Mix with a spatula or wooden spoon until thoroughly incorporated.</a:t>
-            </a:r>
-          </a:p>
-          <a:p>
-            <a:pPr>
-              <a:spcBef>
-                <a:spcPts val="0"/>
-              </a:spcBef>
-              <a:spcAft>
-                <a:spcPts val="200"/>
-              </a:spcAft>
-              <a:buNone/>
-            </a:pPr>
-            <a:r>
-              <a:rPr lang="en-US" sz="1350" b="1">
-                <a:solidFill>
-                  <a:srgbClr val="0F172A"/>
+              <a:t>Form Shaggy Dough — </a:t>
+            </a:r>
+            <a:r>
+              <a:rPr lang="en-US" sz="1300" b="0">
+                <a:solidFill>
+                  <a:srgbClr val="334155"/>
                 </a:solidFill>
                 <a:latin typeface="Calibri"/>
               </a:rPr>
-              <a:t>03  Overnight Counter Rest</a:t>
-            </a:r>
-          </a:p>
-          <a:p>
-            <a:pPr>
-              <a:spcBef>
-                <a:spcPts val="0"/>
-              </a:spcBef>
-              <a:spcAft>
-                <a:spcPts val="0"/>
-              </a:spcAft>
-              <a:buNone/>
-            </a:pPr>
-            <a:r>
-              <a:rPr lang="en-US" sz="1200" b="0">
-                <a:solidFill>
-                  <a:srgbClr val="334155"/>
-                </a:solidFill>
-                <a:latin typeface="Calibri"/>
-              </a:rPr>
-              <a:t>Cover bowl tightly with plastic wrap. Let rest at room temperature for 12 to 18 hours until bubbly and doubled.</a:t>
-            </a:r>
-          </a:p>
-        </p:txBody>
-      </p:sp>
-      <p:sp>
-        <p:nvSpPr>
-          <p:cNvPr id="4" name="Content Placeholder 3"/>
-          <p:cNvSpPr>
-            <a:spLocks noGrp="1"/>
-          </p:cNvSpPr>
-          <p:nvPr>
-            <p:ph idx="2" sz="half"/>
-          </p:nvPr>
-        </p:nvSpPr>
-        <p:spPr>
-          <a:xfrm>
-            <a:off x="4754880" y="1463040"/>
-            <a:ext cx="3657600" cy="4754880"/>
-          </a:xfrm>
-          <a:solidFill>
-            <a:srgbClr val="F8FAFC"/>
-          </a:solidFill>
-          <a:ln w="12700">
-            <a:solidFill>
-              <a:srgbClr val="CBD5E1"/>
-            </a:solidFill>
-          </a:ln>
-        </p:spPr>
-        <p:txBody>
-          <a:bodyPr lIns="256032" rIns="256032" tIns="256032" bIns="256032" wrap="square"/>
-          <a:lstStyle/>
-          <a:p>
-            <a:pPr>
-              <a:spcBef>
-                <a:spcPts val="0"/>
-              </a:spcBef>
-              <a:spcAft>
-                <a:spcPts val="1200"/>
-              </a:spcAft>
-              <a:buNone/>
-            </a:pPr>
-            <a:r>
-              <a:rPr lang="en-US" sz="1100" b="1">
-                <a:solidFill>
-                  <a:srgbClr val="0369A1"/>
-                </a:solidFill>
-                <a:latin typeface="Calibri"/>
-              </a:rPr>
-              <a:t>PHASE 2: PREHEAT &amp; BAKE</a:t>
-            </a:r>
-          </a:p>
-          <a:p>
-            <a:pPr>
-              <a:spcBef>
-                <a:spcPts val="0"/>
-              </a:spcBef>
-              <a:spcAft>
-                <a:spcPts val="200"/>
-              </a:spcAft>
-              <a:buNone/>
-            </a:pPr>
-            <a:r>
-              <a:rPr lang="en-US" sz="1350" b="1">
-                <a:solidFill>
-                  <a:srgbClr val="0F172A"/>
-                </a:solidFill>
-                <a:latin typeface="Calibri"/>
-              </a:rPr>
-              <a:t>04  Preheat Oven &amp; Dutch Oven</a:t>
-            </a:r>
-          </a:p>
-          <a:p>
-            <a:pPr>
+              <a:t>Pour in 1½ cups room-temperature water. Mix with a wooden spoon or spatula until thoroughly incorporated.</a:t>
+            </a:r>
+          </a:p>
+          <a:p>
+            <a:pPr marL="342900" indent="-342900">
               <a:spcBef>
                 <a:spcPts val="0"/>
               </a:spcBef>
               <a:spcAft>
                 <a:spcPts val="1000"/>
               </a:spcAft>
-              <a:buNone/>
+              <a:buAutoNum type="arabicPeriod"/>
             </a:pPr>
             <a:r>
-              <a:rPr lang="en-US" sz="1200" b="0">
-                <a:solidFill>
-                  <a:srgbClr val="334155"/>
+              <a:rPr lang="en-US" sz="1350" b="1">
+                <a:solidFill>
+                  <a:srgbClr val="0F172A"/>
                 </a:solidFill>
                 <a:latin typeface="Calibri"/>
               </a:rPr>
-              <a:t>Place covered cast iron Dutch oven inside oven. Preheat both together to 450°F (230°C) for at least 30 minutes.</a:t>
-            </a:r>
-          </a:p>
-          <a:p>
-            <a:pPr>
-              <a:spcBef>
-                <a:spcPts val="0"/>
-              </a:spcBef>
-              <a:spcAft>
-                <a:spcPts val="200"/>
-              </a:spcAft>
-              <a:buNone/>
-            </a:pPr>
-            <a:r>
-              <a:rPr lang="en-US" sz="1350" b="1">
-                <a:solidFill>
-                  <a:srgbClr val="0F172A"/>
+              <a:t>Overnight Counter Ferment — </a:t>
+            </a:r>
+            <a:r>
+              <a:rPr lang="en-US" sz="1300" b="0">
+                <a:solidFill>
+                  <a:srgbClr val="334155"/>
                 </a:solidFill>
                 <a:latin typeface="Calibri"/>
               </a:rPr>
-              <a:t>05  Shape &amp; Transfer Dough</a:t>
-            </a:r>
-          </a:p>
-          <a:p>
-            <a:pPr>
+              <a:t>Cover bowl tightly with plastic wrap. Let rest at room temperature for 12 to 18 hours until bubbly and doubled.</a:t>
+            </a:r>
+          </a:p>
+          <a:p>
+            <a:pPr marL="342900" indent="-342900">
               <a:spcBef>
                 <a:spcPts val="0"/>
               </a:spcBef>
               <a:spcAft>
                 <a:spcPts val="1000"/>
               </a:spcAft>
-              <a:buNone/>
+              <a:buAutoNum type="arabicPeriod"/>
             </a:pPr>
             <a:r>
-              <a:rPr lang="en-US" sz="1200" b="0">
-                <a:solidFill>
-                  <a:srgbClr val="334155"/>
+              <a:rPr lang="en-US" sz="1350" b="1">
+                <a:solidFill>
+                  <a:srgbClr val="0F172A"/>
                 </a:solidFill>
                 <a:latin typeface="Calibri"/>
               </a:rPr>
-              <a:t>With floured hands, gently turn dough onto a floured counter, shape into a ball, and drop into hot pot.</a:t>
-            </a:r>
-          </a:p>
-          <a:p>
-            <a:pPr>
+              <a:t>Preheat Oven &amp; Dutch Oven — </a:t>
+            </a:r>
+            <a:r>
+              <a:rPr lang="en-US" sz="1300" b="0">
+                <a:solidFill>
+                  <a:srgbClr val="334155"/>
+                </a:solidFill>
+                <a:latin typeface="Calibri"/>
+              </a:rPr>
+              <a:t>Place covered cast iron Dutch oven inside oven. Preheat both together to 450°F (230°C) for at least 30 minutes.</a:t>
+            </a:r>
+          </a:p>
+          <a:p>
+            <a:pPr marL="342900" indent="-342900">
               <a:spcBef>
                 <a:spcPts val="0"/>
               </a:spcBef>
               <a:spcAft>
-                <a:spcPts val="200"/>
+                <a:spcPts val="1000"/>
               </a:spcAft>
-              <a:buNone/>
+              <a:buAutoNum type="arabicPeriod"/>
             </a:pPr>
             <a:r>
               <a:rPr lang="en-US" sz="1350" b="1">
@@ -4103,27 +3950,45 @@
                 </a:solidFill>
                 <a:latin typeface="Calibri"/>
               </a:rPr>
-              <a:t>06  Covered &amp; Uncovered Bake</a:t>
-            </a:r>
-          </a:p>
-          <a:p>
-            <a:pPr>
+              <a:t>Shape &amp; Transfer Dough — </a:t>
+            </a:r>
+            <a:r>
+              <a:rPr lang="en-US" sz="1300" b="0">
+                <a:solidFill>
+                  <a:srgbClr val="334155"/>
+                </a:solidFill>
+                <a:latin typeface="Calibri"/>
+              </a:rPr>
+              <a:t>With generously floured hands, turn dough onto a floured counter, shape into a ball, and drop into hot pot.</a:t>
+            </a:r>
+          </a:p>
+          <a:p>
+            <a:pPr marL="342900" indent="-342900">
               <a:spcBef>
                 <a:spcPts val="0"/>
               </a:spcBef>
               <a:spcAft>
-                <a:spcPts val="0"/>
+                <a:spcPts val="1000"/>
               </a:spcAft>
-              <a:buNone/>
+              <a:buAutoNum type="arabicPeriod"/>
             </a:pPr>
             <a:r>
-              <a:rPr lang="en-US" sz="1200" b="0">
-                <a:solidFill>
-                  <a:srgbClr val="334155"/>
+              <a:rPr lang="en-US" sz="1350" b="1">
+                <a:solidFill>
+                  <a:srgbClr val="0F172A"/>
                 </a:solidFill>
                 <a:latin typeface="Calibri"/>
               </a:rPr>
-              <a:t>Bake covered 30 minutes to trap steam. Remove lid and bake 15–20 minutes more until crust is deeply golden.</a:t>
+              <a:t>Covered &amp; Uncovered Bake — </a:t>
+            </a:r>
+            <a:r>
+              <a:rPr lang="en-US" sz="1300" b="0">
+                <a:solidFill>
+                  <a:srgbClr val="334155"/>
+                </a:solidFill>
+                <a:latin typeface="Calibri"/>
+              </a:rPr>
+              <a:t>Bake covered 30 minutes to trap steam. Remove lid and bake 15 to 20 minutes more until crust is deeply golden.</a:t>
             </a:r>
           </a:p>
         </p:txBody>
@@ -4180,13 +4045,13 @@
             <a:spLocks noGrp="1"/>
           </p:cNvSpPr>
           <p:nvPr>
-            <p:ph idx="1" sz="half"/>
+            <p:ph idx="1"/>
           </p:nvPr>
         </p:nvSpPr>
         <p:spPr>
           <a:xfrm>
             <a:off x="731520" y="1463040"/>
-            <a:ext cx="3657600" cy="4754880"/>
+            <a:ext cx="7680960" cy="4754880"/>
           </a:xfrm>
           <a:solidFill>
             <a:srgbClr val="F8FAFC"/>
@@ -4201,57 +4066,26 @@
           <a:bodyPr lIns="256032" rIns="256032" tIns="256032" bIns="256032" wrap="square"/>
           <a:lstStyle/>
           <a:p>
-            <a:pPr>
+            <a:pPr marL="342900" indent="-342900">
               <a:spcBef>
                 <a:spcPts val="0"/>
               </a:spcBef>
               <a:spcAft>
                 <a:spcPts val="1400"/>
               </a:spcAft>
-              <a:buNone/>
+              <a:buChar char="•"/>
             </a:pPr>
             <a:r>
-              <a:rPr lang="en-US" sz="1100" b="1">
-                <a:solidFill>
-                  <a:srgbClr val="0369A1"/>
+              <a:rPr lang="en-US" sz="1350" b="1">
+                <a:solidFill>
+                  <a:srgbClr val="0F172A"/>
                 </a:solidFill>
                 <a:latin typeface="Calibri"/>
               </a:rPr>
-              <a:t>HANDLING &amp; STORAGE PROTOCOL</a:t>
-            </a:r>
-          </a:p>
-          <a:p>
-            <a:pPr>
-              <a:spcBef>
-                <a:spcPts val="0"/>
-              </a:spcBef>
-              <a:spcAft>
-                <a:spcPts val="300"/>
-              </a:spcAft>
-              <a:buNone/>
-            </a:pPr>
-            <a:r>
-              <a:rPr lang="en-US" sz="1350" b="1">
-                <a:solidFill>
-                  <a:srgbClr val="0F172A"/>
-                </a:solidFill>
-                <a:latin typeface="Calibri"/>
-              </a:rPr>
-              <a:t>Cool Completely Before Slicing</a:t>
-            </a:r>
-          </a:p>
-          <a:p>
-            <a:pPr>
-              <a:spcBef>
-                <a:spcPts val="0"/>
-              </a:spcBef>
-              <a:spcAft>
-                <a:spcPts val="1600"/>
-              </a:spcAft>
-              <a:buNone/>
-            </a:pPr>
-            <a:r>
-              <a:rPr lang="en-US" sz="1250" b="0">
+              <a:t>Cool Completely Before Slicing: </a:t>
+            </a:r>
+            <a:r>
+              <a:rPr lang="en-US" sz="1300" b="0">
                 <a:solidFill>
                   <a:srgbClr val="334155"/>
                 </a:solidFill>
@@ -4261,103 +4095,43 @@
             </a:r>
           </a:p>
           <a:p>
-            <a:pPr>
-              <a:spcBef>
-                <a:spcPts val="0"/>
-              </a:spcBef>
-              <a:spcAft>
-                <a:spcPts val="300"/>
-              </a:spcAft>
-              <a:buNone/>
-            </a:pPr>
-            <a:r>
-              <a:rPr lang="en-US" sz="1350" b="1">
-                <a:solidFill>
-                  <a:srgbClr val="0F172A"/>
-                </a:solidFill>
-                <a:latin typeface="Calibri"/>
-              </a:rPr>
-              <a:t>Preserve the Crust (No Plastic)</a:t>
-            </a:r>
-          </a:p>
-          <a:p>
-            <a:pPr>
-              <a:spcBef>
-                <a:spcPts val="0"/>
-              </a:spcBef>
-              <a:spcAft>
-                <a:spcPts val="0"/>
-              </a:spcAft>
-              <a:buNone/>
-            </a:pPr>
-            <a:r>
-              <a:rPr lang="en-US" sz="1250" b="0">
-                <a:solidFill>
-                  <a:srgbClr val="334155"/>
-                </a:solidFill>
-                <a:latin typeface="Calibri"/>
-              </a:rPr>
-              <a:t>Store cut-side down in a breathable paper bag or wooden bread box at room temperature for up to 3 days. Avoid plastic bags, which trap moisture and soften the crust.</a:t>
-            </a:r>
-          </a:p>
-        </p:txBody>
-      </p:sp>
-      <p:sp>
-        <p:nvSpPr>
-          <p:cNvPr id="4" name="Content Placeholder 3"/>
-          <p:cNvSpPr>
-            <a:spLocks noGrp="1"/>
-          </p:cNvSpPr>
-          <p:nvPr>
-            <p:ph idx="2" sz="half"/>
-          </p:nvPr>
-        </p:nvSpPr>
-        <p:spPr>
-          <a:xfrm>
-            <a:off x="4754880" y="1463040"/>
-            <a:ext cx="3657600" cy="4754880"/>
-          </a:xfrm>
-          <a:solidFill>
-            <a:srgbClr val="F8FAFC"/>
-          </a:solidFill>
-          <a:ln w="12700">
-            <a:solidFill>
-              <a:srgbClr val="CBD5E1"/>
-            </a:solidFill>
-          </a:ln>
-        </p:spPr>
-        <p:txBody>
-          <a:bodyPr lIns="256032" rIns="256032" tIns="256032" bIns="256032" wrap="square"/>
-          <a:lstStyle/>
-          <a:p>
-            <a:pPr>
+            <a:pPr marL="342900" indent="-342900">
               <a:spcBef>
                 <a:spcPts val="0"/>
               </a:spcBef>
               <a:spcAft>
                 <a:spcPts val="1400"/>
               </a:spcAft>
-              <a:buNone/>
+              <a:buChar char="•"/>
             </a:pPr>
             <a:r>
-              <a:rPr lang="en-US" sz="1100" b="1">
-                <a:solidFill>
-                  <a:srgbClr val="0369A1"/>
+              <a:rPr lang="en-US" sz="1350" b="1">
+                <a:solidFill>
+                  <a:srgbClr val="0F172A"/>
                 </a:solidFill>
                 <a:latin typeface="Calibri"/>
               </a:rPr>
-              <a:t>SERVING IDEAS &amp; RESOURCES</a:t>
-            </a:r>
-          </a:p>
-          <a:p>
-            <a:pPr>
+              <a:t>Preserve Crust Crispness: </a:t>
+            </a:r>
+            <a:r>
+              <a:rPr lang="en-US" sz="1300" b="0">
+                <a:solidFill>
+                  <a:srgbClr val="334155"/>
+                </a:solidFill>
+                <a:latin typeface="Calibri"/>
+              </a:rPr>
+              <a:t>Store cut-side down in a breathable paper bag or wooden bread box at room temperature for up to 3 days. Never store in plastic bags, which soften the crust.</a:t>
+            </a:r>
+          </a:p>
+          <a:p>
+            <a:pPr marL="342900" indent="-342900">
               <a:spcBef>
                 <a:spcPts val="0"/>
               </a:spcBef>
               <a:spcAft>
-                <a:spcPts val="300"/>
+                <a:spcPts val="1400"/>
               </a:spcAft>
-              <a:buNone/>
+              <a:buChar char="•"/>
             </a:pPr>
             <a:r>
               <a:rPr lang="en-US" sz="1350" b="1">
@@ -4366,81 +4140,48 @@
                 </a:solidFill>
                 <a:latin typeface="Calibri"/>
               </a:rPr>
-              <a:t>Pairing &amp; Serving Ideas</a:t>
-            </a:r>
-          </a:p>
-          <a:p>
-            <a:pPr>
+              <a:t>Artisanal Serving Pairings: </a:t>
+            </a:r>
+            <a:r>
+              <a:rPr lang="en-US" sz="1300" b="0">
+                <a:solidFill>
+                  <a:srgbClr val="334155"/>
+                </a:solidFill>
+                <a:latin typeface="Calibri"/>
+              </a:rPr>
+              <a:t>Slice thick and serve warm with salted European cultured butter, extra virgin olive oil with flaky sea salt, artisan cheeses, or alongside hearty soups.</a:t>
+            </a:r>
+          </a:p>
+          <a:p>
+            <a:pPr marL="342900" indent="-342900">
               <a:spcBef>
                 <a:spcPts val="0"/>
               </a:spcBef>
               <a:spcAft>
-                <a:spcPts val="1600"/>
+                <a:spcPts val="1400"/>
               </a:spcAft>
-              <a:buNone/>
+              <a:buChar char="•"/>
             </a:pPr>
             <a:r>
-              <a:rPr lang="en-US" sz="1250" b="0">
-                <a:solidFill>
-                  <a:srgbClr val="334155"/>
+              <a:rPr lang="en-US" sz="1350" b="1">
+                <a:solidFill>
+                  <a:srgbClr val="0F172A"/>
                 </a:solidFill>
                 <a:latin typeface="Calibri"/>
               </a:rPr>
-              <a:t>Slice thick and serve warm with salted European cultured butter, extra virgin olive oil with flaky sea salt, artisan cheeses, or dipping into hearty soups.</a:t>
-            </a:r>
-          </a:p>
-          <a:p>
-            <a:pPr>
-              <a:spcBef>
-                <a:spcPts val="0"/>
-              </a:spcBef>
-              <a:spcAft>
-                <a:spcPts val="300"/>
-              </a:spcAft>
-              <a:buNone/>
-            </a:pPr>
-            <a:r>
-              <a:rPr lang="en-US" sz="1350" b="1">
-                <a:solidFill>
-                  <a:srgbClr val="0F172A"/>
+              <a:t>Baker's Companion Guide: </a:t>
+            </a:r>
+            <a:r>
+              <a:rPr lang="en-US" sz="1300" b="0">
+                <a:solidFill>
+                  <a:srgbClr val="334155"/>
                 </a:solidFill>
                 <a:latin typeface="Calibri"/>
               </a:rPr>
-              <a:t>Baker's Companion Guide</a:t>
-            </a:r>
-          </a:p>
-          <a:p>
-            <a:pPr>
-              <a:spcBef>
-                <a:spcPts val="0"/>
-              </a:spcBef>
-              <a:spcAft>
-                <a:spcPts val="600"/>
-              </a:spcAft>
-              <a:buNone/>
-            </a:pPr>
-            <a:r>
-              <a:rPr lang="en-US" sz="1250" b="0">
-                <a:solidFill>
-                  <a:srgbClr val="334155"/>
-                </a:solidFill>
-                <a:latin typeface="Calibri"/>
-              </a:rPr>
-              <a:t>Looking for hydration ratios, whole wheat variations, and troubleshooting tips?</a:t>
-            </a:r>
-          </a:p>
-          <a:p>
-            <a:pPr>
-              <a:spcBef>
-                <a:spcPts val="0"/>
-              </a:spcBef>
-              <a:spcAft>
-                <a:spcPts val="0"/>
-              </a:spcAft>
-              <a:buNone/>
-            </a:pPr>
-            <a:r>
-              <a:rPr lang="en-US" sz="1250" b="1">
+              <a:t>Looking for crumb analysis, hydration scaling, and Dutch oven troubleshooting? </a:t>
+            </a:r>
+            <a:r>
+              <a:rPr lang="en-US" sz="1300" b="1">
                 <a:solidFill>
                   <a:srgbClr val="0369A1"/>
                 </a:solidFill>

</xml_diff>